<commit_message>
update: modify Corp Architecture Overview presentation
</commit_message>
<xml_diff>
--- a/Documentation/Corp Architecture Overview.pptx
+++ b/Documentation/Corp Architecture Overview.pptx
@@ -267,7 +267,7 @@
           <a:p>
             <a:fld id="{08306F49-376E-45A5-AD65-FD4D759E20F3}" type="datetimeFigureOut">
               <a:rPr lang="en-AU" smtClean="0"/>
-              <a:t>17/08/2026</a:t>
+              <a:t>18/08/2026</a:t>
             </a:fld>
             <a:endParaRPr lang="en-AU"/>
           </a:p>
@@ -467,7 +467,7 @@
           <a:p>
             <a:fld id="{08306F49-376E-45A5-AD65-FD4D759E20F3}" type="datetimeFigureOut">
               <a:rPr lang="en-AU" smtClean="0"/>
-              <a:t>17/08/2026</a:t>
+              <a:t>18/08/2026</a:t>
             </a:fld>
             <a:endParaRPr lang="en-AU"/>
           </a:p>
@@ -677,7 +677,7 @@
           <a:p>
             <a:fld id="{08306F49-376E-45A5-AD65-FD4D759E20F3}" type="datetimeFigureOut">
               <a:rPr lang="en-AU" smtClean="0"/>
-              <a:t>17/08/2026</a:t>
+              <a:t>18/08/2026</a:t>
             </a:fld>
             <a:endParaRPr lang="en-AU"/>
           </a:p>
@@ -887,7 +887,7 @@
           <a:p>
             <a:fld id="{08306F49-376E-45A5-AD65-FD4D759E20F3}" type="datetimeFigureOut">
               <a:rPr lang="en-AU" smtClean="0"/>
-              <a:t>17/08/2026</a:t>
+              <a:t>18/08/2026</a:t>
             </a:fld>
             <a:endParaRPr lang="en-AU"/>
           </a:p>
@@ -1179,7 +1179,7 @@
           <a:p>
             <a:fld id="{08306F49-376E-45A5-AD65-FD4D759E20F3}" type="datetimeFigureOut">
               <a:rPr lang="en-AU" smtClean="0"/>
-              <a:t>17/08/2026</a:t>
+              <a:t>18/08/2026</a:t>
             </a:fld>
             <a:endParaRPr lang="en-AU"/>
           </a:p>
@@ -1447,7 +1447,7 @@
           <a:p>
             <a:fld id="{08306F49-376E-45A5-AD65-FD4D759E20F3}" type="datetimeFigureOut">
               <a:rPr lang="en-AU" smtClean="0"/>
-              <a:t>17/08/2026</a:t>
+              <a:t>18/08/2026</a:t>
             </a:fld>
             <a:endParaRPr lang="en-AU"/>
           </a:p>
@@ -1862,7 +1862,7 @@
           <a:p>
             <a:fld id="{08306F49-376E-45A5-AD65-FD4D759E20F3}" type="datetimeFigureOut">
               <a:rPr lang="en-AU" smtClean="0"/>
-              <a:t>17/08/2026</a:t>
+              <a:t>18/08/2026</a:t>
             </a:fld>
             <a:endParaRPr lang="en-AU"/>
           </a:p>
@@ -2004,7 +2004,7 @@
           <a:p>
             <a:fld id="{08306F49-376E-45A5-AD65-FD4D759E20F3}" type="datetimeFigureOut">
               <a:rPr lang="en-AU" smtClean="0"/>
-              <a:t>17/08/2026</a:t>
+              <a:t>18/08/2026</a:t>
             </a:fld>
             <a:endParaRPr lang="en-AU"/>
           </a:p>
@@ -2117,7 +2117,7 @@
           <a:p>
             <a:fld id="{08306F49-376E-45A5-AD65-FD4D759E20F3}" type="datetimeFigureOut">
               <a:rPr lang="en-AU" smtClean="0"/>
-              <a:t>17/08/2026</a:t>
+              <a:t>18/08/2026</a:t>
             </a:fld>
             <a:endParaRPr lang="en-AU"/>
           </a:p>
@@ -2430,7 +2430,7 @@
           <a:p>
             <a:fld id="{08306F49-376E-45A5-AD65-FD4D759E20F3}" type="datetimeFigureOut">
               <a:rPr lang="en-AU" smtClean="0"/>
-              <a:t>17/08/2026</a:t>
+              <a:t>18/08/2026</a:t>
             </a:fld>
             <a:endParaRPr lang="en-AU"/>
           </a:p>
@@ -2719,7 +2719,7 @@
           <a:p>
             <a:fld id="{08306F49-376E-45A5-AD65-FD4D759E20F3}" type="datetimeFigureOut">
               <a:rPr lang="en-AU" smtClean="0"/>
-              <a:t>17/08/2026</a:t>
+              <a:t>18/08/2026</a:t>
             </a:fld>
             <a:endParaRPr lang="en-AU"/>
           </a:p>
@@ -2962,7 +2962,7 @@
           <a:p>
             <a:fld id="{08306F49-376E-45A5-AD65-FD4D759E20F3}" type="datetimeFigureOut">
               <a:rPr lang="en-AU" smtClean="0"/>
-              <a:t>17/08/2026</a:t>
+              <a:t>18/08/2026</a:t>
             </a:fld>
             <a:endParaRPr lang="en-AU"/>
           </a:p>
@@ -3797,7 +3797,7 @@
         </p:blipFill>
         <p:spPr>
           <a:xfrm>
-            <a:off x="312789" y="2639679"/>
+            <a:off x="312789" y="3072813"/>
             <a:ext cx="479426" cy="520701"/>
           </a:xfrm>
           <a:prstGeom prst="rect">
@@ -4062,8 +4062,8 @@
         </p:nvCxnSpPr>
         <p:spPr>
           <a:xfrm rot="16200000" flipH="1">
-            <a:off x="482204" y="3230677"/>
-            <a:ext cx="1245403" cy="1104807"/>
+            <a:off x="698771" y="3447244"/>
+            <a:ext cx="812269" cy="1104807"/>
           </a:xfrm>
           <a:prstGeom prst="curvedConnector2">
             <a:avLst/>
@@ -4339,8 +4339,8 @@
         </p:nvCxnSpPr>
         <p:spPr>
           <a:xfrm rot="16200000" flipH="1">
-            <a:off x="-297812" y="4010693"/>
-            <a:ext cx="2805434" cy="1104807"/>
+            <a:off x="-81245" y="4227260"/>
+            <a:ext cx="2372300" cy="1104807"/>
           </a:xfrm>
           <a:prstGeom prst="curvedConnector2">
             <a:avLst/>
@@ -4944,8 +4944,8 @@
         </p:nvSpPr>
         <p:spPr>
           <a:xfrm>
-            <a:off x="7235846" y="4117540"/>
-            <a:ext cx="837204" cy="504760"/>
+            <a:off x="7238208" y="3996711"/>
+            <a:ext cx="1054597" cy="504760"/>
           </a:xfrm>
           <a:prstGeom prst="rect">
             <a:avLst/>
@@ -4976,11 +4976,256 @@
             <a:pPr algn="ctr"/>
             <a:r>
               <a:rPr lang="en-AU" sz="1200" dirty="0"/>
-              <a:t>Add customer changes</a:t>
-            </a:r>
-          </a:p>
-        </p:txBody>
-      </p:sp>
+              <a:t>Customer adds specialisations</a:t>
+            </a:r>
+          </a:p>
+        </p:txBody>
+      </p:sp>
+      <p:sp>
+        <p:nvSpPr>
+          <p:cNvPr id="18" name="Rectangle 17">
+            <a:extLst>
+              <a:ext uri="{FF2B5EF4-FFF2-40B4-BE49-F238E27FC236}">
+                <a16:creationId xmlns:a16="http://schemas.microsoft.com/office/drawing/2014/main" id="{D6C842BF-1E14-88E2-9183-EEB72A81D152}"/>
+              </a:ext>
+            </a:extLst>
+          </p:cNvPr>
+          <p:cNvSpPr/>
+          <p:nvPr/>
+        </p:nvSpPr>
+        <p:spPr>
+          <a:xfrm>
+            <a:off x="102501" y="2486526"/>
+            <a:ext cx="900000" cy="461442"/>
+          </a:xfrm>
+          <a:prstGeom prst="rect">
+            <a:avLst/>
+          </a:prstGeom>
+          <a:noFill/>
+          <a:ln>
+            <a:noFill/>
+          </a:ln>
+        </p:spPr>
+        <p:style>
+          <a:lnRef idx="2">
+            <a:schemeClr val="dk1"/>
+          </a:lnRef>
+          <a:fillRef idx="1">
+            <a:schemeClr val="lt1"/>
+          </a:fillRef>
+          <a:effectRef idx="0">
+            <a:schemeClr val="dk1"/>
+          </a:effectRef>
+          <a:fontRef idx="minor">
+            <a:schemeClr val="dk1"/>
+          </a:fontRef>
+        </p:style>
+        <p:txBody>
+          <a:bodyPr lIns="0" tIns="0" rIns="0" bIns="0" rtlCol="0" anchor="ctr"/>
+          <a:lstStyle/>
+          <a:p>
+            <a:pPr algn="ctr"/>
+            <a:r>
+              <a:rPr lang="en-AU" sz="1200" dirty="0"/>
+              <a:t>Organisation level Technician</a:t>
+            </a:r>
+          </a:p>
+        </p:txBody>
+      </p:sp>
+      <p:sp>
+        <p:nvSpPr>
+          <p:cNvPr id="28" name="Rectangle 27">
+            <a:extLst>
+              <a:ext uri="{FF2B5EF4-FFF2-40B4-BE49-F238E27FC236}">
+                <a16:creationId xmlns:a16="http://schemas.microsoft.com/office/drawing/2014/main" id="{28CB8AC7-ED8F-465E-25E1-DF5F2CA3F010}"/>
+              </a:ext>
+            </a:extLst>
+          </p:cNvPr>
+          <p:cNvSpPr/>
+          <p:nvPr/>
+        </p:nvSpPr>
+        <p:spPr>
+          <a:xfrm>
+            <a:off x="1031733" y="5397283"/>
+            <a:ext cx="595093" cy="264618"/>
+          </a:xfrm>
+          <a:prstGeom prst="rect">
+            <a:avLst/>
+          </a:prstGeom>
+          <a:noFill/>
+          <a:ln>
+            <a:noFill/>
+          </a:ln>
+        </p:spPr>
+        <p:style>
+          <a:lnRef idx="2">
+            <a:schemeClr val="dk1"/>
+          </a:lnRef>
+          <a:fillRef idx="1">
+            <a:schemeClr val="lt1"/>
+          </a:fillRef>
+          <a:effectRef idx="0">
+            <a:schemeClr val="dk1"/>
+          </a:effectRef>
+          <a:fontRef idx="minor">
+            <a:schemeClr val="dk1"/>
+          </a:fontRef>
+        </p:style>
+        <p:txBody>
+          <a:bodyPr lIns="0" tIns="0" rIns="0" bIns="0" rtlCol="0" anchor="ctr"/>
+          <a:lstStyle/>
+          <a:p>
+            <a:pPr algn="ctr"/>
+            <a:r>
+              <a:rPr lang="en-AU" sz="1200" dirty="0"/>
+              <a:t>Deploy #95</a:t>
+            </a:r>
+          </a:p>
+        </p:txBody>
+      </p:sp>
+      <p:sp>
+        <p:nvSpPr>
+          <p:cNvPr id="30" name="Rectangle 29">
+            <a:extLst>
+              <a:ext uri="{FF2B5EF4-FFF2-40B4-BE49-F238E27FC236}">
+                <a16:creationId xmlns:a16="http://schemas.microsoft.com/office/drawing/2014/main" id="{CDB9701A-55C7-DD15-EC87-31D6B71CFBB5}"/>
+              </a:ext>
+            </a:extLst>
+          </p:cNvPr>
+          <p:cNvSpPr/>
+          <p:nvPr/>
+        </p:nvSpPr>
+        <p:spPr>
+          <a:xfrm>
+            <a:off x="197122" y="6131085"/>
+            <a:ext cx="987065" cy="461442"/>
+          </a:xfrm>
+          <a:prstGeom prst="rect">
+            <a:avLst/>
+          </a:prstGeom>
+          <a:noFill/>
+          <a:ln>
+            <a:noFill/>
+          </a:ln>
+        </p:spPr>
+        <p:style>
+          <a:lnRef idx="2">
+            <a:schemeClr val="dk1"/>
+          </a:lnRef>
+          <a:fillRef idx="1">
+            <a:schemeClr val="lt1"/>
+          </a:fillRef>
+          <a:effectRef idx="0">
+            <a:schemeClr val="dk1"/>
+          </a:effectRef>
+          <a:fontRef idx="minor">
+            <a:schemeClr val="dk1"/>
+          </a:fontRef>
+        </p:style>
+        <p:txBody>
+          <a:bodyPr lIns="0" tIns="0" rIns="0" bIns="0" rtlCol="0" anchor="ctr"/>
+          <a:lstStyle/>
+          <a:p>
+            <a:pPr algn="ctr"/>
+            <a:r>
+              <a:rPr lang="en-AU" sz="1200" dirty="0"/>
+              <a:t>Approve Deployment #95</a:t>
+            </a:r>
+          </a:p>
+        </p:txBody>
+      </p:sp>
+      <p:cxnSp>
+        <p:nvCxnSpPr>
+          <p:cNvPr id="32" name="Connector: Elbow 31">
+            <a:extLst>
+              <a:ext uri="{FF2B5EF4-FFF2-40B4-BE49-F238E27FC236}">
+                <a16:creationId xmlns:a16="http://schemas.microsoft.com/office/drawing/2014/main" id="{F51D9240-9055-7D5B-43A3-A8BAF50DF7E4}"/>
+              </a:ext>
+            </a:extLst>
+          </p:cNvPr>
+          <p:cNvCxnSpPr>
+            <a:cxnSpLocks/>
+            <a:stCxn id="5" idx="1"/>
+            <a:endCxn id="72" idx="2"/>
+          </p:cNvCxnSpPr>
+          <p:nvPr/>
+        </p:nvCxnSpPr>
+        <p:spPr>
+          <a:xfrm rot="10800000" flipH="1" flipV="1">
+            <a:off x="312788" y="3333163"/>
+            <a:ext cx="5787689" cy="2724753"/>
+          </a:xfrm>
+          <a:prstGeom prst="bentConnector4">
+            <a:avLst>
+              <a:gd name="adj1" fmla="val -3950"/>
+              <a:gd name="adj2" fmla="val 123992"/>
+            </a:avLst>
+          </a:prstGeom>
+          <a:ln>
+            <a:tailEnd type="triangle"/>
+          </a:ln>
+        </p:spPr>
+        <p:style>
+          <a:lnRef idx="2">
+            <a:schemeClr val="accent2"/>
+          </a:lnRef>
+          <a:fillRef idx="0">
+            <a:schemeClr val="accent2"/>
+          </a:fillRef>
+          <a:effectRef idx="1">
+            <a:schemeClr val="accent2"/>
+          </a:effectRef>
+          <a:fontRef idx="minor">
+            <a:schemeClr val="tx1"/>
+          </a:fontRef>
+        </p:style>
+      </p:cxnSp>
+      <p:cxnSp>
+        <p:nvCxnSpPr>
+          <p:cNvPr id="40" name="Connector: Elbow 39">
+            <a:extLst>
+              <a:ext uri="{FF2B5EF4-FFF2-40B4-BE49-F238E27FC236}">
+                <a16:creationId xmlns:a16="http://schemas.microsoft.com/office/drawing/2014/main" id="{7CF9E605-4607-D4D3-E7E3-F00C93BB99F0}"/>
+              </a:ext>
+            </a:extLst>
+          </p:cNvPr>
+          <p:cNvCxnSpPr>
+            <a:cxnSpLocks/>
+            <a:stCxn id="5" idx="1"/>
+            <a:endCxn id="73" idx="2"/>
+          </p:cNvCxnSpPr>
+          <p:nvPr/>
+        </p:nvCxnSpPr>
+        <p:spPr>
+          <a:xfrm rot="10800000" flipH="1" flipV="1">
+            <a:off x="312788" y="3333163"/>
+            <a:ext cx="7760261" cy="2724753"/>
+          </a:xfrm>
+          <a:prstGeom prst="bentConnector4">
+            <a:avLst>
+              <a:gd name="adj1" fmla="val -2946"/>
+              <a:gd name="adj2" fmla="val 123698"/>
+            </a:avLst>
+          </a:prstGeom>
+          <a:ln>
+            <a:tailEnd type="triangle"/>
+          </a:ln>
+        </p:spPr>
+        <p:style>
+          <a:lnRef idx="2">
+            <a:schemeClr val="accent2"/>
+          </a:lnRef>
+          <a:fillRef idx="0">
+            <a:schemeClr val="accent2"/>
+          </a:fillRef>
+          <a:effectRef idx="1">
+            <a:schemeClr val="accent2"/>
+          </a:effectRef>
+          <a:fontRef idx="minor">
+            <a:schemeClr val="tx1"/>
+          </a:fontRef>
+        </p:style>
+      </p:cxnSp>
     </p:spTree>
     <p:extLst>
       <p:ext uri="{BB962C8B-B14F-4D97-AF65-F5344CB8AC3E}">

</xml_diff>